<commit_message>
Documentación PC2 con enlace al repositorio
</commit_message>
<xml_diff>
--- a/Presentacion_PC2_SaludCerca.pptx
+++ b/Presentacion_PC2_SaludCerca.pptx
@@ -2,19 +2,19 @@
 <file path=ppt/presentation.xml><?xml version="1.0" encoding="utf-8"?>
 <p:presentation xmlns:p="http://schemas.openxmlformats.org/presentationml/2006/main">
   <p:sldMasterIdLst>
-    <p:sldMasterId xmlns:r="http://schemas.openxmlformats.org/officeDocument/2006/relationships" id="2147483648" r:id="R4c87389c335541b1"/>
+    <p:sldMasterId xmlns:r="http://schemas.openxmlformats.org/officeDocument/2006/relationships" id="2147483648" r:id="R3c60abca9d894e79"/>
   </p:sldMasterIdLst>
   <p:notesMasterIdLst>
-    <p:notesMasterId xmlns:r="http://schemas.openxmlformats.org/officeDocument/2006/relationships" r:id="R2b9ad4b79284422f"/>
+    <p:notesMasterId xmlns:r="http://schemas.openxmlformats.org/officeDocument/2006/relationships" r:id="R858341ce9903409e"/>
   </p:notesMasterIdLst>
   <p:sldIdLst>
-    <p:sldId xmlns:r="http://schemas.openxmlformats.org/officeDocument/2006/relationships" id="256" r:id="R9bd3bd795b0545c2"/>
-    <p:sldId xmlns:r="http://schemas.openxmlformats.org/officeDocument/2006/relationships" id="257" r:id="R285e662cb3144e45"/>
-    <p:sldId xmlns:r="http://schemas.openxmlformats.org/officeDocument/2006/relationships" id="258" r:id="R814189fb3d3441d0"/>
-    <p:sldId xmlns:r="http://schemas.openxmlformats.org/officeDocument/2006/relationships" id="259" r:id="R23f770b1cb9c41a0"/>
-    <p:sldId xmlns:r="http://schemas.openxmlformats.org/officeDocument/2006/relationships" id="260" r:id="R7c1fe204251e46d7"/>
-    <p:sldId xmlns:r="http://schemas.openxmlformats.org/officeDocument/2006/relationships" id="261" r:id="R130af1a94692408c"/>
-    <p:sldId xmlns:r="http://schemas.openxmlformats.org/officeDocument/2006/relationships" id="262" r:id="R23dbd0c40f9e45c6"/>
+    <p:sldId xmlns:r="http://schemas.openxmlformats.org/officeDocument/2006/relationships" id="256" r:id="Re27d4d65e1164675"/>
+    <p:sldId xmlns:r="http://schemas.openxmlformats.org/officeDocument/2006/relationships" id="257" r:id="R7cdfd39930f14342"/>
+    <p:sldId xmlns:r="http://schemas.openxmlformats.org/officeDocument/2006/relationships" id="258" r:id="R2d785ced48894db4"/>
+    <p:sldId xmlns:r="http://schemas.openxmlformats.org/officeDocument/2006/relationships" id="259" r:id="R8cc13bf92b3342ae"/>
+    <p:sldId xmlns:r="http://schemas.openxmlformats.org/officeDocument/2006/relationships" id="260" r:id="Rc37ffcc2d48a4bec"/>
+    <p:sldId xmlns:r="http://schemas.openxmlformats.org/officeDocument/2006/relationships" id="261" r:id="R90fb3d967791408a"/>
+    <p:sldId xmlns:r="http://schemas.openxmlformats.org/officeDocument/2006/relationships" id="262" r:id="Red2576c5734d4a34"/>
   </p:sldIdLst>
   <p:sldSz cx="12192000" cy="6858000"/>
   <p:notesSz cx="6858000" cy="9144000"/>
@@ -589,7 +589,7 @@
           <a:lstStyle xmlns:a="http://schemas.openxmlformats.org/drawingml/2006/main"/>
           <a:p xmlns:a="http://schemas.openxmlformats.org/drawingml/2006/main">
             <a:r>
-              <a:t>Abrir el repositorio real antes de la sustentación. La fecha de entrega confirmada es 16/10/2026. La URL sigue pendiente mientras no se publique y compruebe el acceso. Presentar los seis integrantes.</a:t>
+              <a:t>Abrir https://github.com/anderjp/SaludCerca_PC2 antes de la sustentación. El repositorio es público y contiene el código fuente, el SQL y el README. La fecha de entrega confirmada es 16/10/2026. Presentar los seis integrantes.</a:t>
             </a:r>
             <a:endParaRPr/>
           </a:p>
@@ -1084,7 +1084,7 @@
   </p:cSld>
   <p:clrMap bg1="lt1" tx1="dk1" bg2="lt2" tx2="dk2" accent1="accent1" accent2="accent2" accent3="accent3" accent4="accent4" accent5="accent5" accent6="accent6" hlink="hlink" folHlink="folHlink"/>
   <p:sldLayoutIdLst>
-    <p:sldLayoutId xmlns:r="http://schemas.openxmlformats.org/officeDocument/2006/relationships" id="2147483649" r:id="Rbfd5518b794d41d8"/>
+    <p:sldLayoutId xmlns:r="http://schemas.openxmlformats.org/officeDocument/2006/relationships" id="2147483649" r:id="R4f15901567a5472a"/>
   </p:sldLayoutIdLst>
   <p:hf sldNum="0" hdr="0" ftr="0" dt="0"/>
   <p:txStyles>
@@ -2066,7 +2066,7 @@
           <p:cNvPr id="18" name="Table 0">
             <a:extLst xmlns:a="http://schemas.openxmlformats.org/drawingml/2006/main">
               <a:ext uri="{FF2B5EF4-FFF2-40B4-BE49-F238E27FC236}">
-                <a16:creationId xmlns:a16="http://schemas.microsoft.com/office/drawing/2014/main" id="{31B5D115-8DF9-4825-9783-FE2724CD5EB0}"/>
+                <a16:creationId xmlns:a16="http://schemas.microsoft.com/office/drawing/2014/main" id="{0D7558A2-1573-4814-984F-793D2D0710CD}"/>
               </a:ext>
             </a:extLst>
           </p:cNvPr>
@@ -3251,6 +3251,7 @@
       <p:sp>
         <p:nvSpPr>
           <p:cNvPr id="16" name="Text 13">
+            <ns0:hlinkClick xmlns:ns0="http://schemas.openxmlformats.org/drawingml/2006/main" xmlns:ns1="http://schemas.openxmlformats.org/officeDocument/2006/relationships" ns1:id="rId1"/>
             <a:extLst xmlns:a="http://schemas.openxmlformats.org/drawingml/2006/main">
               <a:ext uri="{FF2B5EF4-FFF2-40B4-BE49-F238E27FC236}">
                 <a16:creationId xmlns:a16="http://schemas.microsoft.com/office/drawing/2014/main" id="{46045CAE-C117-4B36-9DEE-F74B2F89E5FA}"/>
@@ -3288,7 +3289,7 @@
                 <a:ea typeface="Consolas"/>
                 <a:cs typeface="Consolas"/>
               </a:rPr>
-              <a:t>Repositorio pendiente de publicación</a:t>
+              <a:t>github.com/anderjp/SaludCerca_PC2</a:t>
             </a:r>
             <a:endParaRPr sz="1250"/>
           </a:p>
@@ -5936,7 +5937,7 @@
           <p:cNvPr id="6" name="Image 0">
             <a:extLst xmlns:a="http://schemas.openxmlformats.org/drawingml/2006/main">
               <a:ext uri="{FF2B5EF4-FFF2-40B4-BE49-F238E27FC236}">
-                <a16:creationId xmlns:a16="http://schemas.microsoft.com/office/drawing/2014/main" id="{014D1AF2-F5E8-4F27-BE4F-01AC3183D635}"/>
+                <a16:creationId xmlns:a16="http://schemas.microsoft.com/office/drawing/2014/main" id="{AA99E039-B476-4DCE-B4C4-7D70BD364022}"/>
               </a:ext>
             </a:extLst>
           </p:cNvPr>
@@ -5946,7 +5947,7 @@
           <p:nvPr/>
         </p:nvPicPr>
         <p:blipFill>
-          <a:blip xmlns:r="http://schemas.openxmlformats.org/officeDocument/2006/relationships" xmlns:a="http://schemas.openxmlformats.org/drawingml/2006/main" r:embed="Ra65fa70ba973447a"/>
+          <a:blip xmlns:r="http://schemas.openxmlformats.org/officeDocument/2006/relationships" xmlns:a="http://schemas.openxmlformats.org/drawingml/2006/main" r:embed="R9111bd7df7af4f30"/>
           <a:stretch xmlns:a="http://schemas.openxmlformats.org/drawingml/2006/main">
             <a:fillRect l="0" t="0" r="0" b="0"/>
           </a:stretch>
@@ -6058,7 +6059,7 @@
           <p:cNvPr id="9" name="Image 1">
             <a:extLst xmlns:a="http://schemas.openxmlformats.org/drawingml/2006/main">
               <a:ext uri="{FF2B5EF4-FFF2-40B4-BE49-F238E27FC236}">
-                <a16:creationId xmlns:a16="http://schemas.microsoft.com/office/drawing/2014/main" id="{52E29584-D1B3-41AE-A37C-290F55A363E7}"/>
+                <a16:creationId xmlns:a16="http://schemas.microsoft.com/office/drawing/2014/main" id="{F6392066-4D2E-4188-8F57-FD29D11F4431}"/>
               </a:ext>
             </a:extLst>
           </p:cNvPr>
@@ -6068,7 +6069,7 @@
           <p:nvPr/>
         </p:nvPicPr>
         <p:blipFill>
-          <a:blip xmlns:r="http://schemas.openxmlformats.org/officeDocument/2006/relationships" xmlns:a="http://schemas.openxmlformats.org/drawingml/2006/main" r:embed="R7fa7c2fcc0ea4bab"/>
+          <a:blip xmlns:r="http://schemas.openxmlformats.org/officeDocument/2006/relationships" xmlns:a="http://schemas.openxmlformats.org/drawingml/2006/main" r:embed="Re300b6fee8374693"/>
           <a:stretch xmlns:a="http://schemas.openxmlformats.org/drawingml/2006/main">
             <a:fillRect l="0" t="0" r="0" b="0"/>
           </a:stretch>
@@ -6180,7 +6181,7 @@
           <p:cNvPr id="12" name="Image 2">
             <a:extLst xmlns:a="http://schemas.openxmlformats.org/drawingml/2006/main">
               <a:ext uri="{FF2B5EF4-FFF2-40B4-BE49-F238E27FC236}">
-                <a16:creationId xmlns:a16="http://schemas.microsoft.com/office/drawing/2014/main" id="{94A1C341-32E9-4B88-8DC4-5EAA0003722B}"/>
+                <a16:creationId xmlns:a16="http://schemas.microsoft.com/office/drawing/2014/main" id="{BB30FDA1-4D5A-4634-8550-B9D928CCB11E}"/>
               </a:ext>
             </a:extLst>
           </p:cNvPr>
@@ -6190,7 +6191,7 @@
           <p:nvPr/>
         </p:nvPicPr>
         <p:blipFill>
-          <a:blip xmlns:r="http://schemas.openxmlformats.org/officeDocument/2006/relationships" xmlns:a="http://schemas.openxmlformats.org/drawingml/2006/main" r:embed="R7967d9a534a247dd"/>
+          <a:blip xmlns:r="http://schemas.openxmlformats.org/officeDocument/2006/relationships" xmlns:a="http://schemas.openxmlformats.org/drawingml/2006/main" r:embed="R02e9167117574446"/>
           <a:stretch xmlns:a="http://schemas.openxmlformats.org/drawingml/2006/main">
             <a:fillRect l="0" t="0" r="0" b="0"/>
           </a:stretch>
@@ -6302,7 +6303,7 @@
           <p:cNvPr id="15" name="Image 3">
             <a:extLst xmlns:a="http://schemas.openxmlformats.org/drawingml/2006/main">
               <a:ext uri="{FF2B5EF4-FFF2-40B4-BE49-F238E27FC236}">
-                <a16:creationId xmlns:a16="http://schemas.microsoft.com/office/drawing/2014/main" id="{A308CF0D-03D8-4EFA-9855-BDD156681459}"/>
+                <a16:creationId xmlns:a16="http://schemas.microsoft.com/office/drawing/2014/main" id="{AC5E88D6-8D62-4BDF-8F0B-F96CF42E4C7A}"/>
               </a:ext>
             </a:extLst>
           </p:cNvPr>
@@ -6312,7 +6313,7 @@
           <p:nvPr/>
         </p:nvPicPr>
         <p:blipFill>
-          <a:blip xmlns:r="http://schemas.openxmlformats.org/officeDocument/2006/relationships" xmlns:a="http://schemas.openxmlformats.org/drawingml/2006/main" r:embed="Rd7921a57e78746c5"/>
+          <a:blip xmlns:r="http://schemas.openxmlformats.org/officeDocument/2006/relationships" xmlns:a="http://schemas.openxmlformats.org/drawingml/2006/main" r:embed="R5a0c5ea29cef4302"/>
           <a:stretch xmlns:a="http://schemas.openxmlformats.org/drawingml/2006/main">
             <a:fillRect l="0" t="0" r="0" b="0"/>
           </a:stretch>
@@ -6424,7 +6425,7 @@
           <p:cNvPr id="18" name="Image 4">
             <a:extLst xmlns:a="http://schemas.openxmlformats.org/drawingml/2006/main">
               <a:ext uri="{FF2B5EF4-FFF2-40B4-BE49-F238E27FC236}">
-                <a16:creationId xmlns:a16="http://schemas.microsoft.com/office/drawing/2014/main" id="{A90BB4C8-6DCC-4019-9929-699365B36971}"/>
+                <a16:creationId xmlns:a16="http://schemas.microsoft.com/office/drawing/2014/main" id="{C3ACE3D4-F6CC-4415-8B4D-04FC0DB12B61}"/>
               </a:ext>
             </a:extLst>
           </p:cNvPr>
@@ -6434,7 +6435,7 @@
           <p:nvPr/>
         </p:nvPicPr>
         <p:blipFill>
-          <a:blip xmlns:r="http://schemas.openxmlformats.org/officeDocument/2006/relationships" xmlns:a="http://schemas.openxmlformats.org/drawingml/2006/main" r:embed="R295546a09f72487b"/>
+          <a:blip xmlns:r="http://schemas.openxmlformats.org/officeDocument/2006/relationships" xmlns:a="http://schemas.openxmlformats.org/drawingml/2006/main" r:embed="Rb33646faea86489c"/>
           <a:stretch xmlns:a="http://schemas.openxmlformats.org/drawingml/2006/main">
             <a:fillRect l="0" t="0" r="0" b="0"/>
           </a:stretch>
@@ -6678,7 +6679,7 @@
           <p:cNvPr id="6" name="Image 0">
             <a:extLst xmlns:a="http://schemas.openxmlformats.org/drawingml/2006/main">
               <a:ext uri="{FF2B5EF4-FFF2-40B4-BE49-F238E27FC236}">
-                <a16:creationId xmlns:a16="http://schemas.microsoft.com/office/drawing/2014/main" id="{86F426AB-19FF-4D95-99C2-1CE1480CF2D6}"/>
+                <a16:creationId xmlns:a16="http://schemas.microsoft.com/office/drawing/2014/main" id="{37036895-91D0-4323-8324-D81506DD70E1}"/>
               </a:ext>
             </a:extLst>
           </p:cNvPr>
@@ -6688,7 +6689,7 @@
           <p:nvPr/>
         </p:nvPicPr>
         <p:blipFill>
-          <a:blip xmlns:r="http://schemas.openxmlformats.org/officeDocument/2006/relationships" xmlns:a="http://schemas.openxmlformats.org/drawingml/2006/main" r:embed="R20c65ef4c06046aa"/>
+          <a:blip xmlns:r="http://schemas.openxmlformats.org/officeDocument/2006/relationships" xmlns:a="http://schemas.openxmlformats.org/drawingml/2006/main" r:embed="Rab8e91973b2d4200"/>
           <a:stretch xmlns:a="http://schemas.openxmlformats.org/drawingml/2006/main">
             <a:fillRect l="0" t="0" r="0" b="0"/>
           </a:stretch>
@@ -6800,7 +6801,7 @@
           <p:cNvPr id="9" name="Image 1">
             <a:extLst xmlns:a="http://schemas.openxmlformats.org/drawingml/2006/main">
               <a:ext uri="{FF2B5EF4-FFF2-40B4-BE49-F238E27FC236}">
-                <a16:creationId xmlns:a16="http://schemas.microsoft.com/office/drawing/2014/main" id="{2391670A-43AB-4B46-B309-C700E5B94450}"/>
+                <a16:creationId xmlns:a16="http://schemas.microsoft.com/office/drawing/2014/main" id="{1523F5FD-F73A-45EB-93CC-692A423C7D00}"/>
               </a:ext>
             </a:extLst>
           </p:cNvPr>
@@ -6810,7 +6811,7 @@
           <p:nvPr/>
         </p:nvPicPr>
         <p:blipFill>
-          <a:blip xmlns:r="http://schemas.openxmlformats.org/officeDocument/2006/relationships" xmlns:a="http://schemas.openxmlformats.org/drawingml/2006/main" r:embed="R3517e26317d64484"/>
+          <a:blip xmlns:r="http://schemas.openxmlformats.org/officeDocument/2006/relationships" xmlns:a="http://schemas.openxmlformats.org/drawingml/2006/main" r:embed="Rad5a5f3f8b1c4326"/>
           <a:stretch xmlns:a="http://schemas.openxmlformats.org/drawingml/2006/main">
             <a:fillRect l="0" t="0" r="0" b="0"/>
           </a:stretch>
@@ -6922,7 +6923,7 @@
           <p:cNvPr id="12" name="Image 2">
             <a:extLst xmlns:a="http://schemas.openxmlformats.org/drawingml/2006/main">
               <a:ext uri="{FF2B5EF4-FFF2-40B4-BE49-F238E27FC236}">
-                <a16:creationId xmlns:a16="http://schemas.microsoft.com/office/drawing/2014/main" id="{39F07A8B-95C5-48F1-8B40-10D488CF3A9F}"/>
+                <a16:creationId xmlns:a16="http://schemas.microsoft.com/office/drawing/2014/main" id="{D0970DA9-3F63-4061-956E-2C91590E4DD2}"/>
               </a:ext>
             </a:extLst>
           </p:cNvPr>
@@ -6932,7 +6933,7 @@
           <p:nvPr/>
         </p:nvPicPr>
         <p:blipFill>
-          <a:blip xmlns:r="http://schemas.openxmlformats.org/officeDocument/2006/relationships" xmlns:a="http://schemas.openxmlformats.org/drawingml/2006/main" r:embed="Rc1fb9ebd74a04894"/>
+          <a:blip xmlns:r="http://schemas.openxmlformats.org/officeDocument/2006/relationships" xmlns:a="http://schemas.openxmlformats.org/drawingml/2006/main" r:embed="R8a7a7eb008f845fe"/>
           <a:stretch xmlns:a="http://schemas.openxmlformats.org/drawingml/2006/main">
             <a:fillRect l="0" t="0" r="0" b="0"/>
           </a:stretch>
@@ -7044,7 +7045,7 @@
           <p:cNvPr id="15" name="Image 3">
             <a:extLst xmlns:a="http://schemas.openxmlformats.org/drawingml/2006/main">
               <a:ext uri="{FF2B5EF4-FFF2-40B4-BE49-F238E27FC236}">
-                <a16:creationId xmlns:a16="http://schemas.microsoft.com/office/drawing/2014/main" id="{B7CD99FE-6362-4F0A-A822-C5708E6CD182}"/>
+                <a16:creationId xmlns:a16="http://schemas.microsoft.com/office/drawing/2014/main" id="{5BA5015F-C796-4D40-B107-72EF9CDF5072}"/>
               </a:ext>
             </a:extLst>
           </p:cNvPr>
@@ -7054,7 +7055,7 @@
           <p:nvPr/>
         </p:nvPicPr>
         <p:blipFill>
-          <a:blip xmlns:r="http://schemas.openxmlformats.org/officeDocument/2006/relationships" xmlns:a="http://schemas.openxmlformats.org/drawingml/2006/main" r:embed="Ra4289c08af424ad2"/>
+          <a:blip xmlns:r="http://schemas.openxmlformats.org/officeDocument/2006/relationships" xmlns:a="http://schemas.openxmlformats.org/drawingml/2006/main" r:embed="Rea0e779646aa423a"/>
           <a:stretch xmlns:a="http://schemas.openxmlformats.org/drawingml/2006/main">
             <a:fillRect l="0" t="0" r="0" b="0"/>
           </a:stretch>
@@ -12891,10 +12892,10 @@
         <a:srgbClr val="70AD47"/>
       </a:accent6>
       <a:hlink>
-        <a:srgbClr val="0563C1"/>
+        <a:srgbClr val="7FD1B9"/>
       </a:hlink>
       <a:folHlink>
-        <a:srgbClr val="954F72"/>
+        <a:srgbClr val="7FD1B9"/>
       </a:folHlink>
     </a:clrScheme>
     <a:fontScheme name="Office">

</xml_diff>